<commit_message>
final change (I hope)
</commit_message>
<xml_diff>
--- a/presentation.pptx
+++ b/presentation.pptx
@@ -135,7 +135,7 @@
 <file path=ppt/revisionInfo.xml><?xml version="1.0" encoding="utf-8"?>
 <p1510:revInfo xmlns:a="http://schemas.openxmlformats.org/drawingml/2006/main" xmlns:r="http://schemas.openxmlformats.org/officeDocument/2006/relationships" xmlns:p1510="http://schemas.microsoft.com/office/powerpoint/2015/10/main">
   <p1510:revLst>
-    <p1510:client id="{5232C8DC-050B-42FA-910C-E4F22DF42549}" v="122" dt="2026-06-08T14:48:28.189"/>
+    <p1510:client id="{5232C8DC-050B-42FA-910C-E4F22DF42549}" v="180" dt="2026-06-08T15:11:23.987"/>
   </p1510:revLst>
 </p1510:revInfo>
 </file>
@@ -145,7 +145,7 @@
   <pc:docChgLst>
     <pc:chgData name="Alexandre Lietard" userId="4ed4568d-87dc-41a3-b1cd-681653f54c31" providerId="ADAL" clId="{39935140-010E-4189-9B3B-400B83565928}"/>
     <pc:docChg chg="undo custSel addSld delSld modSld sldOrd">
-      <pc:chgData name="Alexandre Lietard" userId="4ed4568d-87dc-41a3-b1cd-681653f54c31" providerId="ADAL" clId="{39935140-010E-4189-9B3B-400B83565928}" dt="2026-06-08T14:48:31.105" v="4972" actId="47"/>
+      <pc:chgData name="Alexandre Lietard" userId="4ed4568d-87dc-41a3-b1cd-681653f54c31" providerId="ADAL" clId="{39935140-010E-4189-9B3B-400B83565928}" dt="2026-06-08T15:12:55.240" v="5194" actId="313"/>
       <pc:docMkLst>
         <pc:docMk/>
       </pc:docMkLst>
@@ -308,7 +308,7 @@
         </pc:picChg>
       </pc:sldChg>
       <pc:sldChg chg="addSp delSp modSp add mod">
-        <pc:chgData name="Alexandre Lietard" userId="4ed4568d-87dc-41a3-b1cd-681653f54c31" providerId="ADAL" clId="{39935140-010E-4189-9B3B-400B83565928}" dt="2026-06-08T07:28:36.977" v="1517"/>
+        <pc:chgData name="Alexandre Lietard" userId="4ed4568d-87dc-41a3-b1cd-681653f54c31" providerId="ADAL" clId="{39935140-010E-4189-9B3B-400B83565928}" dt="2026-06-08T15:06:54.208" v="4979" actId="20577"/>
         <pc:sldMkLst>
           <pc:docMk/>
           <pc:sldMk cId="2925492065" sldId="258"/>
@@ -330,7 +330,7 @@
           </ac:spMkLst>
         </pc:spChg>
         <pc:spChg chg="add mod">
-          <ac:chgData name="Alexandre Lietard" userId="4ed4568d-87dc-41a3-b1cd-681653f54c31" providerId="ADAL" clId="{39935140-010E-4189-9B3B-400B83565928}" dt="2026-06-08T07:28:29.596" v="1516" actId="5793"/>
+          <ac:chgData name="Alexandre Lietard" userId="4ed4568d-87dc-41a3-b1cd-681653f54c31" providerId="ADAL" clId="{39935140-010E-4189-9B3B-400B83565928}" dt="2026-06-08T15:06:54.208" v="4979" actId="20577"/>
           <ac:spMkLst>
             <pc:docMk/>
             <pc:sldMk cId="2925492065" sldId="258"/>
@@ -369,7 +369,7 @@
         </pc:spChg>
       </pc:sldChg>
       <pc:sldChg chg="addSp delSp modSp add mod">
-        <pc:chgData name="Alexandre Lietard" userId="4ed4568d-87dc-41a3-b1cd-681653f54c31" providerId="ADAL" clId="{39935140-010E-4189-9B3B-400B83565928}" dt="2026-06-05T14:42:01.285" v="957" actId="1076"/>
+        <pc:chgData name="Alexandre Lietard" userId="4ed4568d-87dc-41a3-b1cd-681653f54c31" providerId="ADAL" clId="{39935140-010E-4189-9B3B-400B83565928}" dt="2026-06-08T15:07:30.437" v="5046" actId="20577"/>
         <pc:sldMkLst>
           <pc:docMk/>
           <pc:sldMk cId="3911135577" sldId="261"/>
@@ -382,8 +382,16 @@
             <ac:spMk id="2" creationId="{0BA6F3B2-3D7D-3CCB-5F66-99FFBAFD8F8A}"/>
           </ac:spMkLst>
         </pc:spChg>
+        <pc:spChg chg="add mod">
+          <ac:chgData name="Alexandre Lietard" userId="4ed4568d-87dc-41a3-b1cd-681653f54c31" providerId="ADAL" clId="{39935140-010E-4189-9B3B-400B83565928}" dt="2026-06-08T15:07:30.437" v="5046" actId="20577"/>
+          <ac:spMkLst>
+            <pc:docMk/>
+            <pc:sldMk cId="3911135577" sldId="261"/>
+            <ac:spMk id="3" creationId="{4B5A6EEB-3F7A-A540-9FA3-8958350E8423}"/>
+          </ac:spMkLst>
+        </pc:spChg>
         <pc:picChg chg="add mod">
-          <ac:chgData name="Alexandre Lietard" userId="4ed4568d-87dc-41a3-b1cd-681653f54c31" providerId="ADAL" clId="{39935140-010E-4189-9B3B-400B83565928}" dt="2026-06-05T14:42:01.285" v="957" actId="1076"/>
+          <ac:chgData name="Alexandre Lietard" userId="4ed4568d-87dc-41a3-b1cd-681653f54c31" providerId="ADAL" clId="{39935140-010E-4189-9B3B-400B83565928}" dt="2026-06-08T15:07:23.162" v="5013" actId="1076"/>
           <ac:picMkLst>
             <pc:docMk/>
             <pc:sldMk cId="3911135577" sldId="261"/>
@@ -392,21 +400,29 @@
         </pc:picChg>
       </pc:sldChg>
       <pc:sldChg chg="addSp delSp modSp add mod">
-        <pc:chgData name="Alexandre Lietard" userId="4ed4568d-87dc-41a3-b1cd-681653f54c31" providerId="ADAL" clId="{39935140-010E-4189-9B3B-400B83565928}" dt="2026-06-08T12:51:31.688" v="4208" actId="113"/>
+        <pc:chgData name="Alexandre Lietard" userId="4ed4568d-87dc-41a3-b1cd-681653f54c31" providerId="ADAL" clId="{39935140-010E-4189-9B3B-400B83565928}" dt="2026-06-08T15:08:32.224" v="5115" actId="1076"/>
         <pc:sldMkLst>
           <pc:docMk/>
           <pc:sldMk cId="2066845361" sldId="262"/>
         </pc:sldMkLst>
         <pc:spChg chg="mod">
-          <ac:chgData name="Alexandre Lietard" userId="4ed4568d-87dc-41a3-b1cd-681653f54c31" providerId="ADAL" clId="{39935140-010E-4189-9B3B-400B83565928}" dt="2026-06-05T14:43:21.863" v="968" actId="20577"/>
+          <ac:chgData name="Alexandre Lietard" userId="4ed4568d-87dc-41a3-b1cd-681653f54c31" providerId="ADAL" clId="{39935140-010E-4189-9B3B-400B83565928}" dt="2026-06-08T15:08:16.742" v="5102" actId="115"/>
           <ac:spMkLst>
             <pc:docMk/>
             <pc:sldMk cId="2066845361" sldId="262"/>
             <ac:spMk id="2" creationId="{E5489FBD-8B5B-FF25-C987-CBB3174447EC}"/>
           </ac:spMkLst>
         </pc:spChg>
+        <pc:spChg chg="add del mod">
+          <ac:chgData name="Alexandre Lietard" userId="4ed4568d-87dc-41a3-b1cd-681653f54c31" providerId="ADAL" clId="{39935140-010E-4189-9B3B-400B83565928}" dt="2026-06-08T15:08:17.580" v="5104"/>
+          <ac:spMkLst>
+            <pc:docMk/>
+            <pc:sldMk cId="2066845361" sldId="262"/>
+            <ac:spMk id="3" creationId="{375A4F6C-4C4C-42AA-1680-4E699DCFDAD9}"/>
+          </ac:spMkLst>
+        </pc:spChg>
         <pc:spChg chg="add mod">
-          <ac:chgData name="Alexandre Lietard" userId="4ed4568d-87dc-41a3-b1cd-681653f54c31" providerId="ADAL" clId="{39935140-010E-4189-9B3B-400B83565928}" dt="2026-06-08T12:51:31.688" v="4208" actId="113"/>
+          <ac:chgData name="Alexandre Lietard" userId="4ed4568d-87dc-41a3-b1cd-681653f54c31" providerId="ADAL" clId="{39935140-010E-4189-9B3B-400B83565928}" dt="2026-06-08T15:08:28.645" v="5114" actId="20577"/>
           <ac:spMkLst>
             <pc:docMk/>
             <pc:sldMk cId="2066845361" sldId="262"/>
@@ -414,7 +430,7 @@
           </ac:spMkLst>
         </pc:spChg>
         <pc:spChg chg="add mod">
-          <ac:chgData name="Alexandre Lietard" userId="4ed4568d-87dc-41a3-b1cd-681653f54c31" providerId="ADAL" clId="{39935140-010E-4189-9B3B-400B83565928}" dt="2026-06-05T14:45:21.077" v="1181" actId="21"/>
+          <ac:chgData name="Alexandre Lietard" userId="4ed4568d-87dc-41a3-b1cd-681653f54c31" providerId="ADAL" clId="{39935140-010E-4189-9B3B-400B83565928}" dt="2026-06-08T15:08:32.224" v="5115" actId="1076"/>
           <ac:spMkLst>
             <pc:docMk/>
             <pc:sldMk cId="2066845361" sldId="262"/>
@@ -422,7 +438,7 @@
           </ac:spMkLst>
         </pc:spChg>
         <pc:spChg chg="add mod">
-          <ac:chgData name="Alexandre Lietard" userId="4ed4568d-87dc-41a3-b1cd-681653f54c31" providerId="ADAL" clId="{39935140-010E-4189-9B3B-400B83565928}" dt="2026-06-05T14:47:59.806" v="1264" actId="20577"/>
+          <ac:chgData name="Alexandre Lietard" userId="4ed4568d-87dc-41a3-b1cd-681653f54c31" providerId="ADAL" clId="{39935140-010E-4189-9B3B-400B83565928}" dt="2026-06-08T15:08:32.224" v="5115" actId="1076"/>
           <ac:spMkLst>
             <pc:docMk/>
             <pc:sldMk cId="2066845361" sldId="262"/>
@@ -469,7 +485,7 @@
         </pc:picChg>
       </pc:sldChg>
       <pc:sldChg chg="addSp delSp modSp add mod">
-        <pc:chgData name="Alexandre Lietard" userId="4ed4568d-87dc-41a3-b1cd-681653f54c31" providerId="ADAL" clId="{39935140-010E-4189-9B3B-400B83565928}" dt="2026-06-08T10:00:24.201" v="3439" actId="1076"/>
+        <pc:chgData name="Alexandre Lietard" userId="4ed4568d-87dc-41a3-b1cd-681653f54c31" providerId="ADAL" clId="{39935140-010E-4189-9B3B-400B83565928}" dt="2026-06-08T15:10:49.857" v="5127" actId="1076"/>
         <pc:sldMkLst>
           <pc:docMk/>
           <pc:sldMk cId="102544954" sldId="265"/>
@@ -491,7 +507,7 @@
           </ac:spMkLst>
         </pc:spChg>
         <pc:spChg chg="add mod">
-          <ac:chgData name="Alexandre Lietard" userId="4ed4568d-87dc-41a3-b1cd-681653f54c31" providerId="ADAL" clId="{39935140-010E-4189-9B3B-400B83565928}" dt="2026-06-08T10:00:10.922" v="3433" actId="1076"/>
+          <ac:chgData name="Alexandre Lietard" userId="4ed4568d-87dc-41a3-b1cd-681653f54c31" providerId="ADAL" clId="{39935140-010E-4189-9B3B-400B83565928}" dt="2026-06-08T15:09:51.464" v="5116" actId="1076"/>
           <ac:spMkLst>
             <pc:docMk/>
             <pc:sldMk cId="102544954" sldId="265"/>
@@ -499,7 +515,7 @@
           </ac:spMkLst>
         </pc:spChg>
         <pc:spChg chg="add mod">
-          <ac:chgData name="Alexandre Lietard" userId="4ed4568d-87dc-41a3-b1cd-681653f54c31" providerId="ADAL" clId="{39935140-010E-4189-9B3B-400B83565928}" dt="2026-06-08T10:00:10.922" v="3433" actId="1076"/>
+          <ac:chgData name="Alexandre Lietard" userId="4ed4568d-87dc-41a3-b1cd-681653f54c31" providerId="ADAL" clId="{39935140-010E-4189-9B3B-400B83565928}" dt="2026-06-08T15:09:51.464" v="5116" actId="1076"/>
           <ac:spMkLst>
             <pc:docMk/>
             <pc:sldMk cId="102544954" sldId="265"/>
@@ -507,7 +523,7 @@
           </ac:spMkLst>
         </pc:spChg>
         <pc:spChg chg="add mod">
-          <ac:chgData name="Alexandre Lietard" userId="4ed4568d-87dc-41a3-b1cd-681653f54c31" providerId="ADAL" clId="{39935140-010E-4189-9B3B-400B83565928}" dt="2026-06-08T10:00:10.922" v="3433" actId="1076"/>
+          <ac:chgData name="Alexandre Lietard" userId="4ed4568d-87dc-41a3-b1cd-681653f54c31" providerId="ADAL" clId="{39935140-010E-4189-9B3B-400B83565928}" dt="2026-06-08T15:09:51.464" v="5116" actId="1076"/>
           <ac:spMkLst>
             <pc:docMk/>
             <pc:sldMk cId="102544954" sldId="265"/>
@@ -515,7 +531,7 @@
           </ac:spMkLst>
         </pc:spChg>
         <pc:spChg chg="add mod">
-          <ac:chgData name="Alexandre Lietard" userId="4ed4568d-87dc-41a3-b1cd-681653f54c31" providerId="ADAL" clId="{39935140-010E-4189-9B3B-400B83565928}" dt="2026-06-08T10:00:10.922" v="3433" actId="1076"/>
+          <ac:chgData name="Alexandre Lietard" userId="4ed4568d-87dc-41a3-b1cd-681653f54c31" providerId="ADAL" clId="{39935140-010E-4189-9B3B-400B83565928}" dt="2026-06-08T15:09:51.464" v="5116" actId="1076"/>
           <ac:spMkLst>
             <pc:docMk/>
             <pc:sldMk cId="102544954" sldId="265"/>
@@ -523,7 +539,7 @@
           </ac:spMkLst>
         </pc:spChg>
         <pc:spChg chg="add mod">
-          <ac:chgData name="Alexandre Lietard" userId="4ed4568d-87dc-41a3-b1cd-681653f54c31" providerId="ADAL" clId="{39935140-010E-4189-9B3B-400B83565928}" dt="2026-06-08T10:00:24.201" v="3439" actId="1076"/>
+          <ac:chgData name="Alexandre Lietard" userId="4ed4568d-87dc-41a3-b1cd-681653f54c31" providerId="ADAL" clId="{39935140-010E-4189-9B3B-400B83565928}" dt="2026-06-08T15:09:51.464" v="5116" actId="1076"/>
           <ac:spMkLst>
             <pc:docMk/>
             <pc:sldMk cId="102544954" sldId="265"/>
@@ -531,11 +547,19 @@
           </ac:spMkLst>
         </pc:spChg>
         <pc:picChg chg="add mod modCrop">
-          <ac:chgData name="Alexandre Lietard" userId="4ed4568d-87dc-41a3-b1cd-681653f54c31" providerId="ADAL" clId="{39935140-010E-4189-9B3B-400B83565928}" dt="2026-06-08T10:00:10.922" v="3433" actId="1076"/>
+          <ac:chgData name="Alexandre Lietard" userId="4ed4568d-87dc-41a3-b1cd-681653f54c31" providerId="ADAL" clId="{39935140-010E-4189-9B3B-400B83565928}" dt="2026-06-08T15:09:51.464" v="5116" actId="1076"/>
           <ac:picMkLst>
             <pc:docMk/>
             <pc:sldMk cId="102544954" sldId="265"/>
             <ac:picMk id="4" creationId="{5DC3D830-A7A7-52A4-E402-0A776FC69484}"/>
+          </ac:picMkLst>
+        </pc:picChg>
+        <pc:picChg chg="add del mod">
+          <ac:chgData name="Alexandre Lietard" userId="4ed4568d-87dc-41a3-b1cd-681653f54c31" providerId="ADAL" clId="{39935140-010E-4189-9B3B-400B83565928}" dt="2026-06-08T15:10:38.744" v="5123" actId="478"/>
+          <ac:picMkLst>
+            <pc:docMk/>
+            <pc:sldMk cId="102544954" sldId="265"/>
+            <ac:picMk id="13" creationId="{9A1B5B0B-1230-692C-D86A-5F50FB19FA77}"/>
           </ac:picMkLst>
         </pc:picChg>
         <pc:picChg chg="add del">
@@ -546,8 +570,16 @@
             <ac:picMk id="14" creationId="{784858CB-AAA1-A127-295B-CDA7F2D16A81}"/>
           </ac:picMkLst>
         </pc:picChg>
+        <pc:picChg chg="add mod">
+          <ac:chgData name="Alexandre Lietard" userId="4ed4568d-87dc-41a3-b1cd-681653f54c31" providerId="ADAL" clId="{39935140-010E-4189-9B3B-400B83565928}" dt="2026-06-08T15:10:49.857" v="5127" actId="1076"/>
+          <ac:picMkLst>
+            <pc:docMk/>
+            <pc:sldMk cId="102544954" sldId="265"/>
+            <ac:picMk id="15" creationId="{CA83F7EC-98F3-6733-7E63-2605F9FFEF05}"/>
+          </ac:picMkLst>
+        </pc:picChg>
         <pc:cxnChg chg="add mod">
-          <ac:chgData name="Alexandre Lietard" userId="4ed4568d-87dc-41a3-b1cd-681653f54c31" providerId="ADAL" clId="{39935140-010E-4189-9B3B-400B83565928}" dt="2026-06-08T10:00:21.486" v="3438" actId="14100"/>
+          <ac:chgData name="Alexandre Lietard" userId="4ed4568d-87dc-41a3-b1cd-681653f54c31" providerId="ADAL" clId="{39935140-010E-4189-9B3B-400B83565928}" dt="2026-06-08T15:09:51.464" v="5116" actId="1076"/>
           <ac:cxnSpMkLst>
             <pc:docMk/>
             <pc:sldMk cId="102544954" sldId="265"/>
@@ -675,7 +707,7 @@
         </pc:cxnChg>
       </pc:sldChg>
       <pc:sldChg chg="addSp delSp modSp add mod modAnim">
-        <pc:chgData name="Alexandre Lietard" userId="4ed4568d-87dc-41a3-b1cd-681653f54c31" providerId="ADAL" clId="{39935140-010E-4189-9B3B-400B83565928}" dt="2026-06-08T14:27:26.345" v="4347" actId="14100"/>
+        <pc:chgData name="Alexandre Lietard" userId="4ed4568d-87dc-41a3-b1cd-681653f54c31" providerId="ADAL" clId="{39935140-010E-4189-9B3B-400B83565928}" dt="2026-06-08T15:11:23.987" v="5182" actId="20577"/>
         <pc:sldMkLst>
           <pc:docMk/>
           <pc:sldMk cId="1604165579" sldId="267"/>
@@ -745,7 +777,7 @@
           </ac:spMkLst>
         </pc:spChg>
         <pc:spChg chg="add mod">
-          <ac:chgData name="Alexandre Lietard" userId="4ed4568d-87dc-41a3-b1cd-681653f54c31" providerId="ADAL" clId="{39935140-010E-4189-9B3B-400B83565928}" dt="2026-06-08T09:04:17.963" v="2021" actId="14100"/>
+          <ac:chgData name="Alexandre Lietard" userId="4ed4568d-87dc-41a3-b1cd-681653f54c31" providerId="ADAL" clId="{39935140-010E-4189-9B3B-400B83565928}" dt="2026-06-08T15:11:23.987" v="5182" actId="20577"/>
           <ac:spMkLst>
             <pc:docMk/>
             <pc:sldMk cId="1604165579" sldId="267"/>
@@ -882,7 +914,7 @@
         </pc:cxnChg>
       </pc:sldChg>
       <pc:sldChg chg="addSp delSp modSp add mod">
-        <pc:chgData name="Alexandre Lietard" userId="4ed4568d-87dc-41a3-b1cd-681653f54c31" providerId="ADAL" clId="{39935140-010E-4189-9B3B-400B83565928}" dt="2026-06-08T14:11:50.299" v="4240" actId="14100"/>
+        <pc:chgData name="Alexandre Lietard" userId="4ed4568d-87dc-41a3-b1cd-681653f54c31" providerId="ADAL" clId="{39935140-010E-4189-9B3B-400B83565928}" dt="2026-06-08T15:11:56.744" v="5185" actId="1076"/>
         <pc:sldMkLst>
           <pc:docMk/>
           <pc:sldMk cId="567714561" sldId="268"/>
@@ -896,7 +928,7 @@
           </ac:spMkLst>
         </pc:spChg>
         <pc:spChg chg="add mod">
-          <ac:chgData name="Alexandre Lietard" userId="4ed4568d-87dc-41a3-b1cd-681653f54c31" providerId="ADAL" clId="{39935140-010E-4189-9B3B-400B83565928}" dt="2026-06-08T09:07:44.648" v="2298" actId="14100"/>
+          <ac:chgData name="Alexandre Lietard" userId="4ed4568d-87dc-41a3-b1cd-681653f54c31" providerId="ADAL" clId="{39935140-010E-4189-9B3B-400B83565928}" dt="2026-06-08T15:11:56.744" v="5185" actId="1076"/>
           <ac:spMkLst>
             <pc:docMk/>
             <pc:sldMk cId="567714561" sldId="268"/>
@@ -920,7 +952,7 @@
           </ac:spMkLst>
         </pc:spChg>
         <pc:spChg chg="add mod">
-          <ac:chgData name="Alexandre Lietard" userId="4ed4568d-87dc-41a3-b1cd-681653f54c31" providerId="ADAL" clId="{39935140-010E-4189-9B3B-400B83565928}" dt="2026-06-08T09:13:32.473" v="2316" actId="1076"/>
+          <ac:chgData name="Alexandre Lietard" userId="4ed4568d-87dc-41a3-b1cd-681653f54c31" providerId="ADAL" clId="{39935140-010E-4189-9B3B-400B83565928}" dt="2026-06-08T15:11:50.999" v="5184" actId="14100"/>
           <ac:spMkLst>
             <pc:docMk/>
             <pc:sldMk cId="567714561" sldId="268"/>
@@ -960,7 +992,7 @@
           </ac:spMkLst>
         </pc:spChg>
         <pc:spChg chg="add mod">
-          <ac:chgData name="Alexandre Lietard" userId="4ed4568d-87dc-41a3-b1cd-681653f54c31" providerId="ADAL" clId="{39935140-010E-4189-9B3B-400B83565928}" dt="2026-06-08T09:13:58.655" v="2369" actId="1076"/>
+          <ac:chgData name="Alexandre Lietard" userId="4ed4568d-87dc-41a3-b1cd-681653f54c31" providerId="ADAL" clId="{39935140-010E-4189-9B3B-400B83565928}" dt="2026-06-08T15:11:48.658" v="5183" actId="1076"/>
           <ac:spMkLst>
             <pc:docMk/>
             <pc:sldMk cId="567714561" sldId="268"/>
@@ -1064,7 +1096,7 @@
           </ac:picMkLst>
         </pc:picChg>
         <pc:cxnChg chg="add mod">
-          <ac:chgData name="Alexandre Lietard" userId="4ed4568d-87dc-41a3-b1cd-681653f54c31" providerId="ADAL" clId="{39935140-010E-4189-9B3B-400B83565928}" dt="2026-06-08T09:13:26.777" v="2314" actId="14100"/>
+          <ac:chgData name="Alexandre Lietard" userId="4ed4568d-87dc-41a3-b1cd-681653f54c31" providerId="ADAL" clId="{39935140-010E-4189-9B3B-400B83565928}" dt="2026-06-08T15:11:56.744" v="5185" actId="1076"/>
           <ac:cxnSpMkLst>
             <pc:docMk/>
             <pc:sldMk cId="567714561" sldId="268"/>
@@ -1113,7 +1145,7 @@
         </pc:cxnChg>
       </pc:sldChg>
       <pc:sldChg chg="addSp delSp modSp add mod modAnim">
-        <pc:chgData name="Alexandre Lietard" userId="4ed4568d-87dc-41a3-b1cd-681653f54c31" providerId="ADAL" clId="{39935140-010E-4189-9B3B-400B83565928}" dt="2026-06-08T14:24:35.506" v="4311" actId="20577"/>
+        <pc:chgData name="Alexandre Lietard" userId="4ed4568d-87dc-41a3-b1cd-681653f54c31" providerId="ADAL" clId="{39935140-010E-4189-9B3B-400B83565928}" dt="2026-06-08T15:12:38.424" v="5190" actId="14100"/>
         <pc:sldMkLst>
           <pc:docMk/>
           <pc:sldMk cId="2733660550" sldId="269"/>
@@ -1271,7 +1303,7 @@
           </ac:picMkLst>
         </pc:picChg>
         <pc:cxnChg chg="add mod">
-          <ac:chgData name="Alexandre Lietard" userId="4ed4568d-87dc-41a3-b1cd-681653f54c31" providerId="ADAL" clId="{39935140-010E-4189-9B3B-400B83565928}" dt="2026-06-08T09:28:26.173" v="2609" actId="14100"/>
+          <ac:chgData name="Alexandre Lietard" userId="4ed4568d-87dc-41a3-b1cd-681653f54c31" providerId="ADAL" clId="{39935140-010E-4189-9B3B-400B83565928}" dt="2026-06-08T15:12:38.424" v="5190" actId="14100"/>
           <ac:cxnSpMkLst>
             <pc:docMk/>
             <pc:sldMk cId="2733660550" sldId="269"/>
@@ -1287,7 +1319,7 @@
           </ac:cxnSpMkLst>
         </pc:cxnChg>
         <pc:cxnChg chg="add mod">
-          <ac:chgData name="Alexandre Lietard" userId="4ed4568d-87dc-41a3-b1cd-681653f54c31" providerId="ADAL" clId="{39935140-010E-4189-9B3B-400B83565928}" dt="2026-06-08T09:28:48.314" v="2640" actId="14100"/>
+          <ac:chgData name="Alexandre Lietard" userId="4ed4568d-87dc-41a3-b1cd-681653f54c31" providerId="ADAL" clId="{39935140-010E-4189-9B3B-400B83565928}" dt="2026-06-08T15:12:28.445" v="5188" actId="14100"/>
           <ac:cxnSpMkLst>
             <pc:docMk/>
             <pc:sldMk cId="2733660550" sldId="269"/>
@@ -1303,7 +1335,7 @@
           </ac:cxnSpMkLst>
         </pc:cxnChg>
         <pc:cxnChg chg="add mod">
-          <ac:chgData name="Alexandre Lietard" userId="4ed4568d-87dc-41a3-b1cd-681653f54c31" providerId="ADAL" clId="{39935140-010E-4189-9B3B-400B83565928}" dt="2026-06-08T09:29:31.303" v="2718" actId="14100"/>
+          <ac:chgData name="Alexandre Lietard" userId="4ed4568d-87dc-41a3-b1cd-681653f54c31" providerId="ADAL" clId="{39935140-010E-4189-9B3B-400B83565928}" dt="2026-06-08T15:12:31.134" v="5189" actId="14100"/>
           <ac:cxnSpMkLst>
             <pc:docMk/>
             <pc:sldMk cId="2733660550" sldId="269"/>
@@ -1454,13 +1486,13 @@
         </pc:spChg>
       </pc:sldChg>
       <pc:sldChg chg="addSp delSp modSp add mod">
-        <pc:chgData name="Alexandre Lietard" userId="4ed4568d-87dc-41a3-b1cd-681653f54c31" providerId="ADAL" clId="{39935140-010E-4189-9B3B-400B83565928}" dt="2026-06-08T14:12:20.794" v="4261" actId="20577"/>
+        <pc:chgData name="Alexandre Lietard" userId="4ed4568d-87dc-41a3-b1cd-681653f54c31" providerId="ADAL" clId="{39935140-010E-4189-9B3B-400B83565928}" dt="2026-06-08T15:12:18.487" v="5187" actId="20577"/>
         <pc:sldMkLst>
           <pc:docMk/>
           <pc:sldMk cId="1383736688" sldId="272"/>
         </pc:sldMkLst>
         <pc:spChg chg="mod">
-          <ac:chgData name="Alexandre Lietard" userId="4ed4568d-87dc-41a3-b1cd-681653f54c31" providerId="ADAL" clId="{39935140-010E-4189-9B3B-400B83565928}" dt="2026-06-08T09:32:45.791" v="2910" actId="20577"/>
+          <ac:chgData name="Alexandre Lietard" userId="4ed4568d-87dc-41a3-b1cd-681653f54c31" providerId="ADAL" clId="{39935140-010E-4189-9B3B-400B83565928}" dt="2026-06-08T15:12:18.487" v="5187" actId="20577"/>
           <ac:spMkLst>
             <pc:docMk/>
             <pc:sldMk cId="1383736688" sldId="272"/>
@@ -1739,7 +1771,7 @@
         </pc:cxnChg>
       </pc:sldChg>
       <pc:sldChg chg="addSp delSp modSp add mod delAnim">
-        <pc:chgData name="Alexandre Lietard" userId="4ed4568d-87dc-41a3-b1cd-681653f54c31" providerId="ADAL" clId="{39935140-010E-4189-9B3B-400B83565928}" dt="2026-06-08T11:53:59.429" v="4207" actId="20577"/>
+        <pc:chgData name="Alexandre Lietard" userId="4ed4568d-87dc-41a3-b1cd-681653f54c31" providerId="ADAL" clId="{39935140-010E-4189-9B3B-400B83565928}" dt="2026-06-08T15:12:55.240" v="5194" actId="313"/>
         <pc:sldMkLst>
           <pc:docMk/>
           <pc:sldMk cId="728090901" sldId="274"/>
@@ -1769,7 +1801,7 @@
           </ac:spMkLst>
         </pc:spChg>
         <pc:spChg chg="add mod">
-          <ac:chgData name="Alexandre Lietard" userId="4ed4568d-87dc-41a3-b1cd-681653f54c31" providerId="ADAL" clId="{39935140-010E-4189-9B3B-400B83565928}" dt="2026-06-08T11:53:59.429" v="4207" actId="20577"/>
+          <ac:chgData name="Alexandre Lietard" userId="4ed4568d-87dc-41a3-b1cd-681653f54c31" providerId="ADAL" clId="{39935140-010E-4189-9B3B-400B83565928}" dt="2026-06-08T15:12:55.240" v="5194" actId="313"/>
           <ac:spMkLst>
             <pc:docMk/>
             <pc:sldMk cId="728090901" sldId="274"/>
@@ -8602,19 +8634,8 @@
                 <a:latin typeface="Inter 24pt" panose="02000503000000020004" pitchFamily="2" charset="0"/>
                 <a:ea typeface="Inter 24pt" panose="02000503000000020004" pitchFamily="2" charset="0"/>
               </a:rPr>
-              <a:t>Keys are contained in </a:t>
-            </a:r>
-            <a:r>
-              <a:rPr lang="en-US" sz="2000" dirty="0" err="1">
-                <a:latin typeface="Inter 24pt" panose="02000503000000020004" pitchFamily="2" charset="0"/>
-                <a:ea typeface="Inter 24pt" panose="02000503000000020004" pitchFamily="2" charset="0"/>
-              </a:rPr>
-              <a:t>references.bib</a:t>
-            </a:r>
-            <a:endParaRPr lang="en-US" sz="2000" dirty="0">
-              <a:latin typeface="Inter 24pt" panose="02000503000000020004" pitchFamily="2" charset="0"/>
-              <a:ea typeface="Inter 24pt" panose="02000503000000020004" pitchFamily="2" charset="0"/>
-            </a:endParaRPr>
+              <a:t>Keys are contained in the bibliography file, with extension .bib</a:t>
+            </a:r>
           </a:p>
           <a:p>
             <a:r>
@@ -9560,7 +9581,7 @@
         </p:nvCxnSpPr>
         <p:spPr>
           <a:xfrm flipH="1">
-            <a:off x="1849120" y="3088640"/>
+            <a:off x="1858514" y="2549927"/>
             <a:ext cx="620811" cy="0"/>
           </a:xfrm>
           <a:prstGeom prst="straightConnector1">
@@ -9599,7 +9620,7 @@
         </p:nvSpPr>
         <p:spPr>
           <a:xfrm>
-            <a:off x="182530" y="2705705"/>
+            <a:off x="191924" y="2166992"/>
             <a:ext cx="1717390" cy="707886"/>
           </a:xfrm>
           <a:prstGeom prst="rect">
@@ -9716,8 +9737,8 @@
         </p:nvSpPr>
         <p:spPr>
           <a:xfrm>
-            <a:off x="8736962" y="3284221"/>
-            <a:ext cx="307731" cy="948690"/>
+            <a:off x="8143688" y="2707881"/>
+            <a:ext cx="307731" cy="632727"/>
           </a:xfrm>
           <a:prstGeom prst="rightBrace">
             <a:avLst>
@@ -9746,7 +9767,7 @@
           <a:lstStyle/>
           <a:p>
             <a:pPr algn="ctr"/>
-            <a:endParaRPr lang="fr-FR"/>
+            <a:endParaRPr lang="fr-FR" dirty="0"/>
           </a:p>
         </p:txBody>
       </p:sp>
@@ -9764,7 +9785,7 @@
         </p:nvSpPr>
         <p:spPr>
           <a:xfrm>
-            <a:off x="9111623" y="3413591"/>
+            <a:off x="8518349" y="2837251"/>
             <a:ext cx="2623032" cy="707886"/>
           </a:xfrm>
           <a:prstGeom prst="rect">
@@ -10131,7 +10152,7 @@
         <p:spPr>
           <a:xfrm>
             <a:off x="3534714" y="282103"/>
-            <a:ext cx="4979248" cy="861774"/>
+            <a:ext cx="4984057" cy="861774"/>
           </a:xfrm>
           <a:prstGeom prst="rect">
             <a:avLst/>
@@ -10149,7 +10170,7 @@
                 <a:latin typeface="Inter 24pt" panose="02000503000000020004" pitchFamily="2" charset="0"/>
                 <a:ea typeface="Inter 24pt" panose="02000503000000020004" pitchFamily="2" charset="0"/>
               </a:rPr>
-              <a:t>fonction_APA.R</a:t>
+              <a:t>function_APA.R</a:t>
             </a:r>
             <a:endParaRPr lang="fr-FR" sz="5000" b="1" u="sng" dirty="0">
               <a:latin typeface="Inter 24pt" panose="02000503000000020004" pitchFamily="2" charset="0"/>
@@ -11968,8 +11989,8 @@
         </p:nvCxnSpPr>
         <p:spPr>
           <a:xfrm>
-            <a:off x="2906425" y="2307029"/>
-            <a:ext cx="847890" cy="1339344"/>
+            <a:off x="3534508" y="2307029"/>
+            <a:ext cx="219807" cy="1339344"/>
           </a:xfrm>
           <a:prstGeom prst="straightConnector1">
             <a:avLst/>
@@ -12009,8 +12030,8 @@
         </p:nvCxnSpPr>
         <p:spPr>
           <a:xfrm>
-            <a:off x="3930162" y="2448910"/>
-            <a:ext cx="1696011" cy="752995"/>
+            <a:off x="4906108" y="2307029"/>
+            <a:ext cx="720065" cy="894876"/>
           </a:xfrm>
           <a:prstGeom prst="straightConnector1">
             <a:avLst/>
@@ -12088,8 +12109,8 @@
         </p:nvCxnSpPr>
         <p:spPr>
           <a:xfrm>
-            <a:off x="6444762" y="2307029"/>
-            <a:ext cx="1441938" cy="293174"/>
+            <a:off x="6805246" y="2307029"/>
+            <a:ext cx="1081454" cy="293174"/>
           </a:xfrm>
           <a:prstGeom prst="straightConnector1">
             <a:avLst/>
@@ -13311,7 +13332,7 @@
                 <a:latin typeface="Inter 24pt" panose="02000503000000020004" pitchFamily="2" charset="0"/>
                 <a:ea typeface="Inter 24pt" panose="02000503000000020004" pitchFamily="2" charset="0"/>
               </a:rPr>
-              <a:t> of the figure with </a:t>
+              <a:t> of the figure with “</a:t>
             </a:r>
             <a:r>
               <a:rPr lang="en-US" sz="2000" dirty="0" err="1">
@@ -13319,6 +13340,13 @@
                 <a:ea typeface="Inter 24pt" panose="02000503000000020004" pitchFamily="2" charset="0"/>
               </a:rPr>
               <a:t>fig.cap</a:t>
+            </a:r>
+            <a:r>
+              <a:rPr lang="en-US" sz="2000">
+                <a:latin typeface="Inter 24pt" panose="02000503000000020004" pitchFamily="2" charset="0"/>
+                <a:ea typeface="Inter 24pt" panose="02000503000000020004" pitchFamily="2" charset="0"/>
+              </a:rPr>
+              <a:t>”</a:t>
             </a:r>
             <a:endParaRPr lang="en-US" sz="2000" dirty="0">
               <a:latin typeface="Inter 24pt" panose="02000503000000020004" pitchFamily="2" charset="0"/>
@@ -15076,7 +15104,7 @@
                 <a:latin typeface="Inter 24pt" panose="02000503000000020004" pitchFamily="2" charset="0"/>
                 <a:ea typeface="Inter 24pt" panose="02000503000000020004" pitchFamily="2" charset="0"/>
               </a:rPr>
-              <a:t>1 articles of 14 reproducible (and 3 others with minor deviation</a:t>
+              <a:t>1 article out of 14 reproducible (and 3 others with minor deviations)</a:t>
             </a:r>
           </a:p>
           <a:p>
@@ -15403,7 +15431,7 @@
         </p:blipFill>
         <p:spPr>
           <a:xfrm>
-            <a:off x="1690935" y="1940560"/>
+            <a:off x="1690935" y="1361826"/>
             <a:ext cx="8810130" cy="3654327"/>
           </a:xfrm>
           <a:prstGeom prst="rect">
@@ -15411,6 +15439,44 @@
           </a:prstGeom>
         </p:spPr>
       </p:pic>
+      <p:sp>
+        <p:nvSpPr>
+          <p:cNvPr id="3" name="TextBox 2">
+            <a:extLst>
+              <a:ext uri="{FF2B5EF4-FFF2-40B4-BE49-F238E27FC236}">
+                <a16:creationId xmlns:a16="http://schemas.microsoft.com/office/drawing/2014/main" id="{4B5A6EEB-3F7A-A540-9FA3-8958350E8423}"/>
+              </a:ext>
+            </a:extLst>
+          </p:cNvPr>
+          <p:cNvSpPr txBox="1"/>
+          <p:nvPr/>
+        </p:nvSpPr>
+        <p:spPr>
+          <a:xfrm>
+            <a:off x="196898" y="5594887"/>
+            <a:ext cx="10749280" cy="630942"/>
+          </a:xfrm>
+          <a:prstGeom prst="rect">
+            <a:avLst/>
+          </a:prstGeom>
+          <a:noFill/>
+        </p:spPr>
+        <p:txBody>
+          <a:bodyPr wrap="square">
+            <a:spAutoFit/>
+          </a:bodyPr>
+          <a:lstStyle/>
+          <a:p>
+            <a:r>
+              <a:rPr lang="en-US" sz="3500" dirty="0">
+                <a:latin typeface="Inter 24pt" panose="02000503000000020004" pitchFamily="2" charset="0"/>
+                <a:ea typeface="Inter 24pt" panose="02000503000000020004" pitchFamily="2" charset="0"/>
+              </a:rPr>
+              <a:t>Many different ways to do it, just an ex	ample</a:t>
+            </a:r>
+          </a:p>
+        </p:txBody>
+      </p:sp>
     </p:spTree>
     <p:extLst>
       <p:ext uri="{BB962C8B-B14F-4D97-AF65-F5344CB8AC3E}">
@@ -15461,8 +15527,8 @@
         </p:nvSpPr>
         <p:spPr>
           <a:xfrm>
-            <a:off x="4952898" y="104052"/>
-            <a:ext cx="2286203" cy="861774"/>
+            <a:off x="1121721" y="42496"/>
+            <a:ext cx="9948557" cy="923330"/>
           </a:xfrm>
           <a:prstGeom prst="rect">
             <a:avLst/>
@@ -15475,17 +15541,14 @@
           </a:bodyPr>
           <a:lstStyle/>
           <a:p>
-            <a:r>
-              <a:rPr lang="en-US" sz="5000" b="1" u="sng" dirty="0">
+            <a:pPr algn="ctr"/>
+            <a:r>
+              <a:rPr lang="en-US" sz="5400" b="1" u="sng" dirty="0">
                 <a:latin typeface="Inter 24pt" panose="02000503000000020004" pitchFamily="2" charset="0"/>
                 <a:ea typeface="Inter 24pt" panose="02000503000000020004" pitchFamily="2" charset="0"/>
               </a:rPr>
-              <a:t>Quarto</a:t>
-            </a:r>
-            <a:endParaRPr lang="fr-FR" sz="5000" b="1" u="sng" dirty="0">
-              <a:latin typeface="Inter 24pt" panose="02000503000000020004" pitchFamily="2" charset="0"/>
-              <a:ea typeface="Inter 24pt" panose="02000503000000020004" pitchFamily="2" charset="0"/>
-            </a:endParaRPr>
+              <a:t>Results section reproducible?</a:t>
+            </a:r>
           </a:p>
         </p:txBody>
       </p:sp>
@@ -15503,8 +15566,8 @@
         </p:nvSpPr>
         <p:spPr>
           <a:xfrm>
-            <a:off x="653018" y="1678313"/>
-            <a:ext cx="10376834" cy="1477328"/>
+            <a:off x="525696" y="1740803"/>
+            <a:ext cx="10376834" cy="1015663"/>
           </a:xfrm>
           <a:prstGeom prst="rect">
             <a:avLst/>
@@ -15518,6 +15581,16 @@
           <a:lstStyle/>
           <a:p>
             <a:r>
+              <a:rPr lang="en-US" sz="3000" b="1" dirty="0">
+                <a:solidFill>
+                  <a:schemeClr val="accent6"/>
+                </a:solidFill>
+                <a:latin typeface="Inter 24pt" panose="02000503000000020004" pitchFamily="2" charset="0"/>
+                <a:ea typeface="Inter 24pt" panose="02000503000000020004" pitchFamily="2" charset="0"/>
+              </a:rPr>
+              <a:t>Quarto: </a:t>
+            </a:r>
+            <a:r>
               <a:rPr lang="en-US" sz="3000" dirty="0">
                 <a:latin typeface="Inter 24pt" panose="02000503000000020004" pitchFamily="2" charset="0"/>
                 <a:ea typeface="Inter 24pt" panose="02000503000000020004" pitchFamily="2" charset="0"/>
@@ -15536,16 +15609,7 @@
                 <a:latin typeface="Inter 24pt" panose="02000503000000020004" pitchFamily="2" charset="0"/>
                 <a:ea typeface="Inter 24pt" panose="02000503000000020004" pitchFamily="2" charset="0"/>
               </a:rPr>
-              <a:t>with more features and more friendly.</a:t>
-            </a:r>
-          </a:p>
-          <a:p>
-            <a:r>
-              <a:rPr lang="en-US" sz="3000" dirty="0">
-                <a:latin typeface="Inter 24pt" panose="02000503000000020004" pitchFamily="2" charset="0"/>
-                <a:ea typeface="Inter 24pt" panose="02000503000000020004" pitchFamily="2" charset="0"/>
-              </a:rPr>
-              <a:t>https://quarto.org/</a:t>
+              <a:t>with more features and more friendly. https://quarto.org/</a:t>
             </a:r>
           </a:p>
         </p:txBody>
@@ -15564,7 +15628,7 @@
         </p:nvSpPr>
         <p:spPr>
           <a:xfrm>
-            <a:off x="653018" y="3273433"/>
+            <a:off x="525696" y="3088238"/>
             <a:ext cx="10376834" cy="1477328"/>
           </a:xfrm>
           <a:prstGeom prst="rect">
@@ -15629,7 +15693,7 @@
         </p:nvSpPr>
         <p:spPr>
           <a:xfrm>
-            <a:off x="653018" y="4868553"/>
+            <a:off x="525696" y="4683358"/>
             <a:ext cx="10376834" cy="1015663"/>
           </a:xfrm>
           <a:prstGeom prst="rect">
@@ -16159,7 +16223,7 @@
         </p:blipFill>
         <p:spPr>
           <a:xfrm>
-            <a:off x="3007869" y="3017696"/>
+            <a:off x="3007869" y="1619719"/>
             <a:ext cx="4264309" cy="1548190"/>
           </a:xfrm>
           <a:prstGeom prst="rect">
@@ -16181,7 +16245,7 @@
         </p:nvSpPr>
         <p:spPr>
           <a:xfrm>
-            <a:off x="7272178" y="3278106"/>
+            <a:off x="7272178" y="1880129"/>
             <a:ext cx="307731" cy="609834"/>
           </a:xfrm>
           <a:prstGeom prst="rightBrace">
@@ -16229,7 +16293,7 @@
         </p:nvSpPr>
         <p:spPr>
           <a:xfrm>
-            <a:off x="7729351" y="3256998"/>
+            <a:off x="7729351" y="1859021"/>
             <a:ext cx="4462648" cy="630942"/>
           </a:xfrm>
           <a:prstGeom prst="rect">
@@ -16267,7 +16331,7 @@
         </p:nvSpPr>
         <p:spPr>
           <a:xfrm>
-            <a:off x="7290195" y="3989697"/>
+            <a:off x="7290195" y="2591720"/>
             <a:ext cx="307731" cy="609834"/>
           </a:xfrm>
           <a:prstGeom prst="rightBrace">
@@ -16315,7 +16379,7 @@
         </p:nvSpPr>
         <p:spPr>
           <a:xfrm>
-            <a:off x="7729352" y="3968589"/>
+            <a:off x="7729352" y="2570612"/>
             <a:ext cx="4462648" cy="630942"/>
           </a:xfrm>
           <a:prstGeom prst="rect">
@@ -16355,7 +16419,7 @@
         </p:nvCxnSpPr>
         <p:spPr>
           <a:xfrm flipH="1">
-            <a:off x="2153920" y="3572469"/>
+            <a:off x="2153920" y="2174492"/>
             <a:ext cx="853949" cy="1121451"/>
           </a:xfrm>
           <a:prstGeom prst="straightConnector1">
@@ -16394,7 +16458,7 @@
         </p:nvSpPr>
         <p:spPr>
           <a:xfrm>
-            <a:off x="253650" y="4693920"/>
+            <a:off x="253650" y="3295943"/>
             <a:ext cx="2591150" cy="707886"/>
           </a:xfrm>
           <a:prstGeom prst="rect">
@@ -16429,6 +16493,36 @@
           </a:p>
         </p:txBody>
       </p:sp>
+      <p:pic>
+        <p:nvPicPr>
+          <p:cNvPr id="15" name="Picture 14">
+            <a:extLst>
+              <a:ext uri="{FF2B5EF4-FFF2-40B4-BE49-F238E27FC236}">
+                <a16:creationId xmlns:a16="http://schemas.microsoft.com/office/drawing/2014/main" id="{CA83F7EC-98F3-6733-7E63-2605F9FFEF05}"/>
+              </a:ext>
+            </a:extLst>
+          </p:cNvPr>
+          <p:cNvPicPr>
+            <a:picLocks noChangeAspect="1"/>
+          </p:cNvPicPr>
+          <p:nvPr/>
+        </p:nvPicPr>
+        <p:blipFill>
+          <a:blip r:embed="rId3"/>
+          <a:stretch>
+            <a:fillRect/>
+          </a:stretch>
+        </p:blipFill>
+        <p:spPr>
+          <a:xfrm>
+            <a:off x="253650" y="4163097"/>
+            <a:ext cx="2973207" cy="2536537"/>
+          </a:xfrm>
+          <a:prstGeom prst="rect">
+            <a:avLst/>
+          </a:prstGeom>
+        </p:spPr>
+      </p:pic>
     </p:spTree>
     <p:extLst>
       <p:ext uri="{BB962C8B-B14F-4D97-AF65-F5344CB8AC3E}">

</xml_diff>